<commit_message>
Add missing slide 20: Five Pillars of Regional Security Architecture (NORTH_CENTRAL_SECURITY_20SLIDE_FAILSAFE.pptx)
</commit_message>
<xml_diff>
--- a/NORTH_CENTRAL_SECURITY_20SLIDE_FAILSAFE.pptx
+++ b/NORTH_CENTRAL_SECURITY_20SLIDE_FAILSAFE.pptx
@@ -25,6 +25,7 @@
     <p:sldId id="271" r:id="rId22"/>
     <p:sldId id="272" r:id="rId23"/>
     <p:sldId id="273" r:id="rId24"/>
+    <p:sldId id="279" r:id="rId30"/>
     <p:sldId id="274" r:id="rId25"/>
     <p:sldId id="275" r:id="rId26"/>
     <p:sldId id="276" r:id="rId27"/>
@@ -3148,7 +3149,7 @@
                 </a:solidFill>
                 <a:latin typeface="Segoe UI"/>
               </a:rPr>
-              <a:t>01 / 23</a:t>
+              <a:t>01 / 24</a:t>
             </a:r>
           </a:p>
         </p:txBody>
@@ -3384,7 +3385,7 @@
                 </a:solidFill>
                 <a:latin typeface="Segoe UI"/>
               </a:rPr>
-              <a:t>10 / 23</a:t>
+              <a:t>10 / 24</a:t>
             </a:r>
           </a:p>
         </p:txBody>
@@ -3585,7 +3586,7 @@
                 </a:solidFill>
                 <a:latin typeface="Segoe UI"/>
               </a:rPr>
-              <a:t>11 / 23</a:t>
+              <a:t>11 / 24</a:t>
             </a:r>
           </a:p>
         </p:txBody>
@@ -3751,7 +3752,7 @@
                 </a:solidFill>
                 <a:latin typeface="Segoe UI"/>
               </a:rPr>
-              <a:t>12 / 23</a:t>
+              <a:t>12 / 24</a:t>
             </a:r>
           </a:p>
         </p:txBody>
@@ -4231,7 +4232,7 @@
                 </a:solidFill>
                 <a:latin typeface="Segoe UI"/>
               </a:rPr>
-              <a:t>13 / 23</a:t>
+              <a:t>13 / 24</a:t>
             </a:r>
           </a:p>
         </p:txBody>
@@ -4467,7 +4468,7 @@
                 </a:solidFill>
                 <a:latin typeface="Segoe UI"/>
               </a:rPr>
-              <a:t>14 / 23</a:t>
+              <a:t>14 / 24</a:t>
             </a:r>
           </a:p>
         </p:txBody>
@@ -4703,7 +4704,7 @@
                 </a:solidFill>
                 <a:latin typeface="Segoe UI"/>
               </a:rPr>
-              <a:t>15 / 23</a:t>
+              <a:t>15 / 24</a:t>
             </a:r>
           </a:p>
         </p:txBody>
@@ -4904,7 +4905,7 @@
                 </a:solidFill>
                 <a:latin typeface="Segoe UI"/>
               </a:rPr>
-              <a:t>16 / 23</a:t>
+              <a:t>16 / 24</a:t>
             </a:r>
           </a:p>
         </p:txBody>
@@ -5105,7 +5106,7 @@
                 </a:solidFill>
                 <a:latin typeface="Segoe UI"/>
               </a:rPr>
-              <a:t>17 / 23</a:t>
+              <a:t>17 / 24</a:t>
             </a:r>
           </a:p>
         </p:txBody>
@@ -5306,7 +5307,7 @@
                 </a:solidFill>
                 <a:latin typeface="Segoe UI"/>
               </a:rPr>
-              <a:t>18 / 23</a:t>
+              <a:t>18 / 24</a:t>
             </a:r>
           </a:p>
         </p:txBody>
@@ -5507,7 +5508,7 @@
                 </a:solidFill>
                 <a:latin typeface="Segoe UI"/>
               </a:rPr>
-              <a:t>19 / 23</a:t>
+              <a:t>19 / 24</a:t>
             </a:r>
           </a:p>
         </p:txBody>
@@ -5708,7 +5709,7 @@
                 </a:solidFill>
                 <a:latin typeface="Segoe UI"/>
               </a:rPr>
-              <a:t>02 / 23</a:t>
+              <a:t>02 / 24</a:t>
             </a:r>
           </a:p>
         </p:txBody>
@@ -6757,7 +6758,7 @@
                 </a:solidFill>
                 <a:latin typeface="Segoe UI"/>
               </a:rPr>
-              <a:t>20 / 23</a:t>
+              <a:t>20 / 24</a:t>
             </a:r>
           </a:p>
         </p:txBody>
@@ -7283,269 +7284,309 @@
         </p:nvSpPr>
         <p:spPr>
           <a:xfrm>
-            <a:off x="10634472" y="228600"/>
-            <a:ext cx="1371600" cy="457200"/>
-          </a:xfrm>
-          <a:prstGeom prst="rect">
-            <a:avLst/>
-          </a:prstGeom>
-          <a:noFill/>
-        </p:spPr>
-        <p:txBody>
-          <a:bodyPr wrap="square">
-            <a:spAutoFit/>
-          </a:bodyPr>
-          <a:lstStyle/>
-          <a:p>
-            <a:pPr algn="r"/>
-            <a:r>
-              <a:rPr sz="1200" b="0" i="0">
+            <a:off x="640080" y="457200"/>
+            <a:ext cx="9966960" cy="320040"/>
+          </a:xfrm>
+          <a:prstGeom prst="rect">
+            <a:avLst/>
+          </a:prstGeom>
+          <a:noFill/>
+        </p:spPr>
+        <p:txBody>
+          <a:bodyPr wrap="square">
+            <a:spAutoFit/>
+          </a:bodyPr>
+          <a:lstStyle/>
+          <a:p>
+            <a:pPr algn="l"/>
+            <a:r>
+              <a:rPr sz="1300" b="0" i="0">
+                <a:solidFill>
+                  <a:srgbClr val="2FD8C9"/>
+                </a:solidFill>
+                <a:latin typeface="Segoe UI"/>
+              </a:rPr>
+              <a:t>NEW SECURITY ARCHITECTURE · REGIONAL FRAMEWORK</a:t>
+            </a:r>
+          </a:p>
+        </p:txBody>
+      </p:sp>
+      <p:sp>
+        <p:nvSpPr>
+          <p:cNvPr id="3" name="TextBox 2"/>
+          <p:cNvSpPr txBox="1"/>
+          <p:nvPr/>
+        </p:nvSpPr>
+        <p:spPr>
+          <a:xfrm>
+            <a:off x="640080" y="777240"/>
+            <a:ext cx="9966960" cy="548640"/>
+          </a:xfrm>
+          <a:prstGeom prst="rect">
+            <a:avLst/>
+          </a:prstGeom>
+          <a:noFill/>
+        </p:spPr>
+        <p:txBody>
+          <a:bodyPr wrap="square">
+            <a:spAutoFit/>
+          </a:bodyPr>
+          <a:lstStyle/>
+          <a:p>
+            <a:pPr algn="l"/>
+            <a:r>
+              <a:rPr sz="2300" b="1" i="0">
+                <a:solidFill>
+                  <a:srgbClr val="2FD8C9"/>
+                </a:solidFill>
+                <a:latin typeface="Segoe UI"/>
+              </a:rPr>
+              <a:t>Five Pillars of the Regional Security Architecture</a:t>
+            </a:r>
+          </a:p>
+        </p:txBody>
+      </p:sp>
+      <p:sp>
+        <p:nvSpPr>
+          <p:cNvPr id="4" name="TextBox 3"/>
+          <p:cNvSpPr txBox="1"/>
+          <p:nvPr/>
+        </p:nvSpPr>
+        <p:spPr>
+          <a:xfrm>
+            <a:off x="640080" y="1417320"/>
+            <a:ext cx="9966960" cy="658368"/>
+          </a:xfrm>
+          <a:prstGeom prst="rect">
+            <a:avLst/>
+          </a:prstGeom>
+          <a:noFill/>
+        </p:spPr>
+        <p:txBody>
+          <a:bodyPr wrap="square">
+            <a:spAutoFit/>
+          </a:bodyPr>
+          <a:lstStyle/>
+          <a:p>
+            <a:pPr algn="l"/>
+            <a:r>
+              <a:rPr sz="1300" b="0" i="0">
+                <a:solidFill>
+                  <a:srgbClr val="F2EFE6"/>
+                </a:solidFill>
+                <a:latin typeface="Segoe UI"/>
+              </a:rPr>
+              <a:t>1. Strategic Coordination — a North Central Regional Security Council bringing together the states, the Federal Government, security agencies, traditional institutions and other critical stakeholders.</a:t>
+            </a:r>
+          </a:p>
+        </p:txBody>
+      </p:sp>
+      <p:sp>
+        <p:nvSpPr>
+          <p:cNvPr id="5" name="TextBox 4"/>
+          <p:cNvSpPr txBox="1"/>
+          <p:nvPr/>
+        </p:nvSpPr>
+        <p:spPr>
+          <a:xfrm>
+            <a:off x="640080" y="2103120"/>
+            <a:ext cx="9966960" cy="658368"/>
+          </a:xfrm>
+          <a:prstGeom prst="rect">
+            <a:avLst/>
+          </a:prstGeom>
+          <a:noFill/>
+        </p:spPr>
+        <p:txBody>
+          <a:bodyPr wrap="square">
+            <a:spAutoFit/>
+          </a:bodyPr>
+          <a:lstStyle/>
+          <a:p>
+            <a:pPr algn="l"/>
+            <a:r>
+              <a:rPr sz="1300" b="0" i="0">
+                <a:solidFill>
+                  <a:srgbClr val="F2EFE6"/>
+                </a:solidFill>
+                <a:latin typeface="Segoe UI"/>
+              </a:rPr>
+              <a:t>2. Intelligence &amp; Early Warning — a Regional Intelligence and Security Fusion Centre, linked to every state and Local Government, so threats are identified and addressed before they become crises.</a:t>
+            </a:r>
+          </a:p>
+        </p:txBody>
+      </p:sp>
+      <p:sp>
+        <p:nvSpPr>
+          <p:cNvPr id="6" name="TextBox 5"/>
+          <p:cNvSpPr txBox="1"/>
+          <p:nvPr/>
+        </p:nvSpPr>
+        <p:spPr>
+          <a:xfrm>
+            <a:off x="640080" y="2788920"/>
+            <a:ext cx="9966960" cy="658368"/>
+          </a:xfrm>
+          <a:prstGeom prst="rect">
+            <a:avLst/>
+          </a:prstGeom>
+          <a:noFill/>
+        </p:spPr>
+        <p:txBody>
+          <a:bodyPr wrap="square">
+            <a:spAutoFit/>
+          </a:bodyPr>
+          <a:lstStyle/>
+          <a:p>
+            <a:pPr algn="l"/>
+            <a:r>
+              <a:rPr sz="1300" b="0" i="0">
+                <a:solidFill>
+                  <a:srgbClr val="F2EFE6"/>
+                </a:solidFill>
+                <a:latin typeface="Segoe UI"/>
+              </a:rPr>
+              <a:t>3. Community Resilience — the Local Government and the community as the foundation of early warning, conflict prevention and public confidence.</a:t>
+            </a:r>
+          </a:p>
+        </p:txBody>
+      </p:sp>
+      <p:sp>
+        <p:nvSpPr>
+          <p:cNvPr id="7" name="TextBox 6"/>
+          <p:cNvSpPr txBox="1"/>
+          <p:nvPr/>
+        </p:nvSpPr>
+        <p:spPr>
+          <a:xfrm>
+            <a:off x="640080" y="3474720"/>
+            <a:ext cx="9966960" cy="658368"/>
+          </a:xfrm>
+          <a:prstGeom prst="rect">
+            <a:avLst/>
+          </a:prstGeom>
+          <a:noFill/>
+        </p:spPr>
+        <p:txBody>
+          <a:bodyPr wrap="square">
+            <a:spAutoFit/>
+          </a:bodyPr>
+          <a:lstStyle/>
+          <a:p>
+            <a:pPr algn="l"/>
+            <a:r>
+              <a:rPr sz="1300" b="0" i="0">
+                <a:solidFill>
+                  <a:srgbClr val="F2EFE6"/>
+                </a:solidFill>
+                <a:latin typeface="Segoe UI"/>
+              </a:rPr>
+              <a:t>4. Technology &amp; Infrastructure Protection — intelligence, communications, surveillance, forensics and emergency response integrated into the region's development system; security by design in every major project.</a:t>
+            </a:r>
+          </a:p>
+        </p:txBody>
+      </p:sp>
+      <p:sp>
+        <p:nvSpPr>
+          <p:cNvPr id="8" name="TextBox 7"/>
+          <p:cNvSpPr txBox="1"/>
+          <p:nvPr/>
+        </p:nvSpPr>
+        <p:spPr>
+          <a:xfrm>
+            <a:off x="640080" y="4160520"/>
+            <a:ext cx="9966960" cy="658368"/>
+          </a:xfrm>
+          <a:prstGeom prst="rect">
+            <a:avLst/>
+          </a:prstGeom>
+          <a:noFill/>
+        </p:spPr>
+        <p:txBody>
+          <a:bodyPr wrap="square">
+            <a:spAutoFit/>
+          </a:bodyPr>
+          <a:lstStyle/>
+          <a:p>
+            <a:pPr algn="l"/>
+            <a:r>
+              <a:rPr sz="1300" b="0" i="0">
+                <a:solidFill>
+                  <a:srgbClr val="F2EFE6"/>
+                </a:solidFill>
+                <a:latin typeface="Segoe UI"/>
+              </a:rPr>
+              <a:t>5. Sustainable Financing &amp; Human Capacity — a North Central Security Endowment Fund, and mobilisation of the region's vast pool of experienced military, intelligence, police, technical and professional personnel.</a:t>
+            </a:r>
+          </a:p>
+        </p:txBody>
+      </p:sp>
+      <p:sp>
+        <p:nvSpPr>
+          <p:cNvPr id="9" name="TextBox 8"/>
+          <p:cNvSpPr txBox="1"/>
+          <p:nvPr/>
+        </p:nvSpPr>
+        <p:spPr>
+          <a:xfrm>
+            <a:off x="640080" y="4892040"/>
+            <a:ext cx="9966960" cy="822960"/>
+          </a:xfrm>
+          <a:prstGeom prst="rect">
+            <a:avLst/>
+          </a:prstGeom>
+          <a:noFill/>
+        </p:spPr>
+        <p:txBody>
+          <a:bodyPr wrap="square">
+            <a:spAutoFit/>
+          </a:bodyPr>
+          <a:lstStyle/>
+          <a:p>
+            <a:pPr algn="l"/>
+            <a:r>
+              <a:rPr sz="1400" b="1" i="1">
                 <a:solidFill>
                   <a:srgbClr val="C9A24B"/>
                 </a:solidFill>
                 <a:latin typeface="Segoe UI"/>
               </a:rPr>
-              <a:t>21 / 23</a:t>
-            </a:r>
-          </a:p>
-        </p:txBody>
-      </p:sp>
-      <p:sp>
-        <p:nvSpPr>
-          <p:cNvPr id="3" name="TextBox 2"/>
-          <p:cNvSpPr txBox="1"/>
-          <p:nvPr/>
-        </p:nvSpPr>
-        <p:spPr>
-          <a:xfrm>
-            <a:off x="822960" y="1051560"/>
-            <a:ext cx="9509760" cy="365760"/>
-          </a:xfrm>
-          <a:prstGeom prst="rect">
-            <a:avLst/>
-          </a:prstGeom>
-          <a:noFill/>
-        </p:spPr>
-        <p:txBody>
-          <a:bodyPr wrap="square">
-            <a:spAutoFit/>
-          </a:bodyPr>
-          <a:lstStyle/>
-          <a:p>
-            <a:pPr algn="ctr"/>
-            <a:r>
-              <a:rPr sz="1300" b="0" i="0">
-                <a:solidFill>
-                  <a:srgbClr val="9FBFA9"/>
-                </a:solidFill>
-                <a:latin typeface="Segoe UI"/>
-              </a:rPr>
-              <a:t>THE NORTH-CENTRAL SECURITY COMPACT</a:t>
-            </a:r>
-          </a:p>
-        </p:txBody>
-      </p:sp>
-      <p:sp>
-        <p:nvSpPr>
-          <p:cNvPr id="4" name="TextBox 3"/>
-          <p:cNvSpPr txBox="1"/>
-          <p:nvPr/>
-        </p:nvSpPr>
-        <p:spPr>
-          <a:xfrm>
-            <a:off x="640080" y="1417320"/>
-            <a:ext cx="9875520" cy="914400"/>
-          </a:xfrm>
-          <a:prstGeom prst="rect">
-            <a:avLst/>
-          </a:prstGeom>
-          <a:noFill/>
-        </p:spPr>
-        <p:txBody>
-          <a:bodyPr wrap="square">
-            <a:spAutoFit/>
-          </a:bodyPr>
-          <a:lstStyle/>
-          <a:p>
-            <a:pPr algn="ctr"/>
-            <a:r>
-              <a:rPr sz="2800" b="1" i="0">
+              <a:t>Our ambition should be very clear: a North Central where farmers can farm, businesses can invest, children can go to school, communities can live in peace, infrastructure can function and development can continue without fear or disruption.</a:t>
+            </a:r>
+          </a:p>
+        </p:txBody>
+      </p:sp>
+      <p:sp>
+        <p:nvSpPr>
+          <p:cNvPr id="10" name="TextBox 9"/>
+          <p:cNvSpPr txBox="1"/>
+          <p:nvPr/>
+        </p:nvSpPr>
+        <p:spPr>
+          <a:xfrm>
+            <a:off x="640080" y="5989320"/>
+            <a:ext cx="9966960" cy="502920"/>
+          </a:xfrm>
+          <a:prstGeom prst="rect">
+            <a:avLst/>
+          </a:prstGeom>
+          <a:noFill/>
+        </p:spPr>
+        <p:txBody>
+          <a:bodyPr wrap="square">
+            <a:spAutoFit/>
+          </a:bodyPr>
+          <a:lstStyle/>
+          <a:p>
+            <a:pPr algn="l"/>
+            <a:r>
+              <a:rPr sz="1200" b="1" i="0">
                 <a:solidFill>
                   <a:srgbClr val="C9A24B"/>
                 </a:solidFill>
                 <a:latin typeface="Segoe UI"/>
               </a:rPr>
-              <a:t>Seven Commitments</a:t>
-            </a:r>
-          </a:p>
-        </p:txBody>
-      </p:sp>
-      <p:sp>
-        <p:nvSpPr>
-          <p:cNvPr id="5" name="TextBox 4"/>
-          <p:cNvSpPr txBox="1"/>
-          <p:nvPr/>
-        </p:nvSpPr>
-        <p:spPr>
-          <a:xfrm>
-            <a:off x="822960" y="2286000"/>
-            <a:ext cx="9509760" cy="3291840"/>
-          </a:xfrm>
-          <a:prstGeom prst="rect">
-            <a:avLst/>
-          </a:prstGeom>
-          <a:noFill/>
-        </p:spPr>
-        <p:txBody>
-          <a:bodyPr wrap="square">
-            <a:spAutoFit/>
-          </a:bodyPr>
-          <a:lstStyle/>
-          <a:p>
-            <a:pPr>
-              <a:spcAft>
-                <a:spcPts val="600"/>
-              </a:spcAft>
-            </a:pPr>
-            <a:r>
-              <a:rPr sz="1500">
-                <a:solidFill>
-                  <a:srgbClr val="F2EFE6"/>
-                </a:solidFill>
-                <a:latin typeface="Segoe UI"/>
-              </a:rPr>
-              <a:t>1. One Threat Picture — we share intelligence</a:t>
-            </a:r>
-          </a:p>
-          <a:p>
-            <a:pPr>
-              <a:spcAft>
-                <a:spcPts val="600"/>
-              </a:spcAft>
-            </a:pPr>
-            <a:r>
-              <a:rPr sz="1500">
-                <a:solidFill>
-                  <a:srgbClr val="F2EFE6"/>
-                </a:solidFill>
-                <a:latin typeface="Segoe UI"/>
-              </a:rPr>
-              <a:t>2. One Early-Warning System — we listen to communities</a:t>
-            </a:r>
-          </a:p>
-          <a:p>
-            <a:pPr>
-              <a:spcAft>
-                <a:spcPts val="600"/>
-              </a:spcAft>
-            </a:pPr>
-            <a:r>
-              <a:rPr sz="1500">
-                <a:solidFill>
-                  <a:srgbClr val="F2EFE6"/>
-                </a:solidFill>
-                <a:latin typeface="Segoe UI"/>
-              </a:rPr>
-              <a:t>3. One Rapid-Response Philosophy — before massacres, not after</a:t>
-            </a:r>
-          </a:p>
-          <a:p>
-            <a:pPr>
-              <a:spcAft>
-                <a:spcPts val="600"/>
-              </a:spcAft>
-            </a:pPr>
-            <a:r>
-              <a:rPr sz="1500">
-                <a:solidFill>
-                  <a:srgbClr val="F2EFE6"/>
-                </a:solidFill>
-                <a:latin typeface="Segoe UI"/>
-              </a:rPr>
-              <a:t>4. One Professional Standard — discipline, law, dignity</a:t>
-            </a:r>
-          </a:p>
-          <a:p>
-            <a:pPr>
-              <a:spcAft>
-                <a:spcPts val="600"/>
-              </a:spcAft>
-            </a:pPr>
-            <a:r>
-              <a:rPr sz="1500">
-                <a:solidFill>
-                  <a:srgbClr val="F2EFE6"/>
-                </a:solidFill>
-                <a:latin typeface="Segoe UI"/>
-              </a:rPr>
-              <a:t>5. One Regional Approach — no state-border cover</a:t>
-            </a:r>
-          </a:p>
-          <a:p>
-            <a:pPr>
-              <a:spcAft>
-                <a:spcPts val="600"/>
-              </a:spcAft>
-            </a:pPr>
-            <a:r>
-              <a:rPr sz="1500">
-                <a:solidFill>
-                  <a:srgbClr val="F2EFE6"/>
-                </a:solidFill>
-                <a:latin typeface="Segoe UI"/>
-              </a:rPr>
-              <a:t>6. One Development Agenda — secure and rebuild together</a:t>
-            </a:r>
-          </a:p>
-          <a:p>
-            <a:pPr>
-              <a:spcAft>
-                <a:spcPts val="600"/>
-              </a:spcAft>
-            </a:pPr>
-            <a:r>
-              <a:rPr sz="1500">
-                <a:solidFill>
-                  <a:srgbClr val="F2EFE6"/>
-                </a:solidFill>
-                <a:latin typeface="Segoe UI"/>
-              </a:rPr>
-              <a:t>7. One Measure of Success — the safety and dignity of the citizen</a:t>
-            </a:r>
-          </a:p>
-        </p:txBody>
-      </p:sp>
-      <p:sp>
-        <p:nvSpPr>
-          <p:cNvPr id="6" name="TextBox 5"/>
-          <p:cNvSpPr txBox="1"/>
-          <p:nvPr/>
-        </p:nvSpPr>
-        <p:spPr>
-          <a:xfrm>
-            <a:off x="822960" y="5806440"/>
-            <a:ext cx="9509760" cy="685800"/>
-          </a:xfrm>
-          <a:prstGeom prst="rect">
-            <a:avLst/>
-          </a:prstGeom>
-          <a:noFill/>
-        </p:spPr>
-        <p:txBody>
-          <a:bodyPr wrap="square">
-            <a:spAutoFit/>
-          </a:bodyPr>
-          <a:lstStyle/>
-          <a:p>
-            <a:pPr algn="ctr"/>
-            <a:r>
-              <a:rPr sz="1500" b="1" i="0">
-                <a:solidFill>
-                  <a:srgbClr val="C9A24B"/>
-                </a:solidFill>
-                <a:latin typeface="Segoe UI"/>
-              </a:rPr>
-              <a:t>SAY: Ask the summit to adopt all seven, together, as one compact.</a:t>
+              <a:t>SAY: Five pillars, one architecture — coordination, intelligence, community, technology, and the financing and people to sustain all four.</a:t>
             </a:r>
           </a:p>
         </p:txBody>
@@ -7606,7 +7647,7 @@
                 </a:solidFill>
                 <a:latin typeface="Segoe UI"/>
               </a:rPr>
-              <a:t>22 / 23</a:t>
+              <a:t>22 / 24</a:t>
             </a:r>
           </a:p>
         </p:txBody>
@@ -7641,7 +7682,7 @@
                 </a:solidFill>
                 <a:latin typeface="Segoe UI"/>
               </a:rPr>
-              <a:t>CLOSING</a:t>
+              <a:t>THE NORTH-CENTRAL SECURITY COMPACT</a:t>
             </a:r>
           </a:p>
         </p:txBody>
@@ -7654,8 +7695,8 @@
         </p:nvSpPr>
         <p:spPr>
           <a:xfrm>
-            <a:off x="822960" y="2011680"/>
-            <a:ext cx="9509760" cy="1463040"/>
+            <a:off x="640080" y="1417320"/>
+            <a:ext cx="9875520" cy="914400"/>
           </a:xfrm>
           <a:prstGeom prst="rect">
             <a:avLst/>
@@ -7670,27 +7711,162 @@
           <a:p>
             <a:pPr algn="ctr"/>
             <a:r>
-              <a:rPr sz="1900" b="0" i="1">
+              <a:rPr sz="2800" b="1" i="0">
+                <a:solidFill>
+                  <a:srgbClr val="C9A24B"/>
+                </a:solidFill>
+                <a:latin typeface="Segoe UI"/>
+              </a:rPr>
+              <a:t>Seven Commitments</a:t>
+            </a:r>
+          </a:p>
+        </p:txBody>
+      </p:sp>
+      <p:sp>
+        <p:nvSpPr>
+          <p:cNvPr id="5" name="TextBox 4"/>
+          <p:cNvSpPr txBox="1"/>
+          <p:nvPr/>
+        </p:nvSpPr>
+        <p:spPr>
+          <a:xfrm>
+            <a:off x="822960" y="2286000"/>
+            <a:ext cx="9509760" cy="3291840"/>
+          </a:xfrm>
+          <a:prstGeom prst="rect">
+            <a:avLst/>
+          </a:prstGeom>
+          <a:noFill/>
+        </p:spPr>
+        <p:txBody>
+          <a:bodyPr wrap="square">
+            <a:spAutoFit/>
+          </a:bodyPr>
+          <a:lstStyle/>
+          <a:p>
+            <a:pPr>
+              <a:spcAft>
+                <a:spcPts val="600"/>
+              </a:spcAft>
+            </a:pPr>
+            <a:r>
+              <a:rPr sz="1500">
                 <a:solidFill>
                   <a:srgbClr val="F2EFE6"/>
                 </a:solidFill>
                 <a:latin typeface="Segoe UI"/>
               </a:rPr>
-              <a:t>"If every local government across the North-Central states is empowered, accountable and connected — we begin to build a regional security shield."</a:t>
-            </a:r>
-          </a:p>
-        </p:txBody>
-      </p:sp>
-      <p:sp>
-        <p:nvSpPr>
-          <p:cNvPr id="5" name="TextBox 4"/>
-          <p:cNvSpPr txBox="1"/>
-          <p:nvPr/>
-        </p:nvSpPr>
-        <p:spPr>
-          <a:xfrm>
-            <a:off x="822960" y="3657600"/>
-            <a:ext cx="9509760" cy="1188720"/>
+              <a:t>1. One Threat Picture — we share intelligence</a:t>
+            </a:r>
+          </a:p>
+          <a:p>
+            <a:pPr>
+              <a:spcAft>
+                <a:spcPts val="600"/>
+              </a:spcAft>
+            </a:pPr>
+            <a:r>
+              <a:rPr sz="1500">
+                <a:solidFill>
+                  <a:srgbClr val="F2EFE6"/>
+                </a:solidFill>
+                <a:latin typeface="Segoe UI"/>
+              </a:rPr>
+              <a:t>2. One Early-Warning System — we listen to communities</a:t>
+            </a:r>
+          </a:p>
+          <a:p>
+            <a:pPr>
+              <a:spcAft>
+                <a:spcPts val="600"/>
+              </a:spcAft>
+            </a:pPr>
+            <a:r>
+              <a:rPr sz="1500">
+                <a:solidFill>
+                  <a:srgbClr val="F2EFE6"/>
+                </a:solidFill>
+                <a:latin typeface="Segoe UI"/>
+              </a:rPr>
+              <a:t>3. One Rapid-Response Philosophy — before massacres, not after</a:t>
+            </a:r>
+          </a:p>
+          <a:p>
+            <a:pPr>
+              <a:spcAft>
+                <a:spcPts val="600"/>
+              </a:spcAft>
+            </a:pPr>
+            <a:r>
+              <a:rPr sz="1500">
+                <a:solidFill>
+                  <a:srgbClr val="F2EFE6"/>
+                </a:solidFill>
+                <a:latin typeface="Segoe UI"/>
+              </a:rPr>
+              <a:t>4. One Professional Standard — discipline, law, dignity</a:t>
+            </a:r>
+          </a:p>
+          <a:p>
+            <a:pPr>
+              <a:spcAft>
+                <a:spcPts val="600"/>
+              </a:spcAft>
+            </a:pPr>
+            <a:r>
+              <a:rPr sz="1500">
+                <a:solidFill>
+                  <a:srgbClr val="F2EFE6"/>
+                </a:solidFill>
+                <a:latin typeface="Segoe UI"/>
+              </a:rPr>
+              <a:t>5. One Regional Approach — no state-border cover</a:t>
+            </a:r>
+          </a:p>
+          <a:p>
+            <a:pPr>
+              <a:spcAft>
+                <a:spcPts val="600"/>
+              </a:spcAft>
+            </a:pPr>
+            <a:r>
+              <a:rPr sz="1500">
+                <a:solidFill>
+                  <a:srgbClr val="F2EFE6"/>
+                </a:solidFill>
+                <a:latin typeface="Segoe UI"/>
+              </a:rPr>
+              <a:t>6. One Development Agenda — secure and rebuild together</a:t>
+            </a:r>
+          </a:p>
+          <a:p>
+            <a:pPr>
+              <a:spcAft>
+                <a:spcPts val="600"/>
+              </a:spcAft>
+            </a:pPr>
+            <a:r>
+              <a:rPr sz="1500">
+                <a:solidFill>
+                  <a:srgbClr val="F2EFE6"/>
+                </a:solidFill>
+                <a:latin typeface="Segoe UI"/>
+              </a:rPr>
+              <a:t>7. One Measure of Success — the safety and dignity of the citizen</a:t>
+            </a:r>
+          </a:p>
+        </p:txBody>
+      </p:sp>
+      <p:sp>
+        <p:nvSpPr>
+          <p:cNvPr id="6" name="TextBox 5"/>
+          <p:cNvSpPr txBox="1"/>
+          <p:nvPr/>
+        </p:nvSpPr>
+        <p:spPr>
+          <a:xfrm>
+            <a:off x="822960" y="5806440"/>
+            <a:ext cx="9509760" cy="685800"/>
           </a:xfrm>
           <a:prstGeom prst="rect">
             <a:avLst/>
@@ -7705,48 +7881,13 @@
           <a:p>
             <a:pPr algn="ctr"/>
             <a:r>
-              <a:rPr sz="1800" b="1" i="0">
+              <a:rPr sz="1500" b="1" i="0">
                 <a:solidFill>
                   <a:srgbClr val="C9A24B"/>
                 </a:solidFill>
                 <a:latin typeface="Segoe UI"/>
               </a:rPr>
-              <a:t>He simply wants to arrive alive. That is the standard by which we must judge ourselves. And it is not beyond the capacity of Nigeria.</a:t>
-            </a:r>
-          </a:p>
-        </p:txBody>
-      </p:sp>
-      <p:sp>
-        <p:nvSpPr>
-          <p:cNvPr id="6" name="TextBox 5"/>
-          <p:cNvSpPr txBox="1"/>
-          <p:nvPr/>
-        </p:nvSpPr>
-        <p:spPr>
-          <a:xfrm>
-            <a:off x="822960" y="6126480"/>
-            <a:ext cx="9509760" cy="320040"/>
-          </a:xfrm>
-          <a:prstGeom prst="rect">
-            <a:avLst/>
-          </a:prstGeom>
-          <a:noFill/>
-        </p:spPr>
-        <p:txBody>
-          <a:bodyPr wrap="square">
-            <a:spAutoFit/>
-          </a:bodyPr>
-          <a:lstStyle/>
-          <a:p>
-            <a:pPr algn="ctr"/>
-            <a:r>
-              <a:rPr sz="900" b="0" i="0">
-                <a:solidFill>
-                  <a:srgbClr val="9FBFA9"/>
-                </a:solidFill>
-                <a:latin typeface="Segoe UI"/>
-              </a:rPr>
-              <a:t>AVM MONDAY RIKU MORGAN (RTD) · NORTH-CENTRAL SECURITY SUMMIT · 2026</a:t>
+              <a:t>SAY: Ask the summit to adopt all seven, together, as one compact.</a:t>
             </a:r>
           </a:p>
         </p:txBody>
@@ -7807,7 +7948,208 @@
                 </a:solidFill>
                 <a:latin typeface="Segoe UI"/>
               </a:rPr>
-              <a:t>23 / 23</a:t>
+              <a:t>23 / 24</a:t>
+            </a:r>
+          </a:p>
+        </p:txBody>
+      </p:sp>
+      <p:sp>
+        <p:nvSpPr>
+          <p:cNvPr id="3" name="TextBox 2"/>
+          <p:cNvSpPr txBox="1"/>
+          <p:nvPr/>
+        </p:nvSpPr>
+        <p:spPr>
+          <a:xfrm>
+            <a:off x="822960" y="1051560"/>
+            <a:ext cx="9509760" cy="365760"/>
+          </a:xfrm>
+          <a:prstGeom prst="rect">
+            <a:avLst/>
+          </a:prstGeom>
+          <a:noFill/>
+        </p:spPr>
+        <p:txBody>
+          <a:bodyPr wrap="square">
+            <a:spAutoFit/>
+          </a:bodyPr>
+          <a:lstStyle/>
+          <a:p>
+            <a:pPr algn="ctr"/>
+            <a:r>
+              <a:rPr sz="1300" b="0" i="0">
+                <a:solidFill>
+                  <a:srgbClr val="9FBFA9"/>
+                </a:solidFill>
+                <a:latin typeface="Segoe UI"/>
+              </a:rPr>
+              <a:t>CLOSING</a:t>
+            </a:r>
+          </a:p>
+        </p:txBody>
+      </p:sp>
+      <p:sp>
+        <p:nvSpPr>
+          <p:cNvPr id="4" name="TextBox 3"/>
+          <p:cNvSpPr txBox="1"/>
+          <p:nvPr/>
+        </p:nvSpPr>
+        <p:spPr>
+          <a:xfrm>
+            <a:off x="822960" y="2011680"/>
+            <a:ext cx="9509760" cy="1463040"/>
+          </a:xfrm>
+          <a:prstGeom prst="rect">
+            <a:avLst/>
+          </a:prstGeom>
+          <a:noFill/>
+        </p:spPr>
+        <p:txBody>
+          <a:bodyPr wrap="square">
+            <a:spAutoFit/>
+          </a:bodyPr>
+          <a:lstStyle/>
+          <a:p>
+            <a:pPr algn="ctr"/>
+            <a:r>
+              <a:rPr sz="1900" b="0" i="1">
+                <a:solidFill>
+                  <a:srgbClr val="F2EFE6"/>
+                </a:solidFill>
+                <a:latin typeface="Segoe UI"/>
+              </a:rPr>
+              <a:t>"If every local government across the North-Central states is empowered, accountable and connected — we begin to build a regional security shield."</a:t>
+            </a:r>
+          </a:p>
+        </p:txBody>
+      </p:sp>
+      <p:sp>
+        <p:nvSpPr>
+          <p:cNvPr id="5" name="TextBox 4"/>
+          <p:cNvSpPr txBox="1"/>
+          <p:nvPr/>
+        </p:nvSpPr>
+        <p:spPr>
+          <a:xfrm>
+            <a:off x="822960" y="3657600"/>
+            <a:ext cx="9509760" cy="1188720"/>
+          </a:xfrm>
+          <a:prstGeom prst="rect">
+            <a:avLst/>
+          </a:prstGeom>
+          <a:noFill/>
+        </p:spPr>
+        <p:txBody>
+          <a:bodyPr wrap="square">
+            <a:spAutoFit/>
+          </a:bodyPr>
+          <a:lstStyle/>
+          <a:p>
+            <a:pPr algn="ctr"/>
+            <a:r>
+              <a:rPr sz="1800" b="1" i="0">
+                <a:solidFill>
+                  <a:srgbClr val="C9A24B"/>
+                </a:solidFill>
+                <a:latin typeface="Segoe UI"/>
+              </a:rPr>
+              <a:t>He simply wants to arrive alive. That is the standard by which we must judge ourselves. And it is not beyond the capacity of Nigeria.</a:t>
+            </a:r>
+          </a:p>
+        </p:txBody>
+      </p:sp>
+      <p:sp>
+        <p:nvSpPr>
+          <p:cNvPr id="6" name="TextBox 5"/>
+          <p:cNvSpPr txBox="1"/>
+          <p:nvPr/>
+        </p:nvSpPr>
+        <p:spPr>
+          <a:xfrm>
+            <a:off x="822960" y="6126480"/>
+            <a:ext cx="9509760" cy="320040"/>
+          </a:xfrm>
+          <a:prstGeom prst="rect">
+            <a:avLst/>
+          </a:prstGeom>
+          <a:noFill/>
+        </p:spPr>
+        <p:txBody>
+          <a:bodyPr wrap="square">
+            <a:spAutoFit/>
+          </a:bodyPr>
+          <a:lstStyle/>
+          <a:p>
+            <a:pPr algn="ctr"/>
+            <a:r>
+              <a:rPr sz="900" b="0" i="0">
+                <a:solidFill>
+                  <a:srgbClr val="9FBFA9"/>
+                </a:solidFill>
+                <a:latin typeface="Segoe UI"/>
+              </a:rPr>
+              <a:t>AVM MONDAY RIKU MORGAN (RTD) · NORTH-CENTRAL SECURITY SUMMIT · 2026</a:t>
+            </a:r>
+          </a:p>
+        </p:txBody>
+      </p:sp>
+    </p:spTree>
+  </p:cSld>
+  <p:clrMapOvr>
+    <a:masterClrMapping/>
+  </p:clrMapOvr>
+</p:sld>
+</file>
+
+<file path=ppt/slides/slide24.xml><?xml version="1.0" encoding="utf-8"?>
+<p:sld xmlns:a="http://schemas.openxmlformats.org/drawingml/2006/main" xmlns:p="http://schemas.openxmlformats.org/presentationml/2006/main" xmlns:r="http://schemas.openxmlformats.org/officeDocument/2006/relationships">
+  <p:cSld>
+    <p:bg>
+      <p:bgPr>
+        <a:solidFill>
+          <a:srgbClr val="0D1A13"/>
+        </a:solidFill>
+        <a:effectLst/>
+      </p:bgPr>
+    </p:bg>
+    <p:spTree>
+      <p:nvGrpSpPr>
+        <p:cNvPr id="1" name=""/>
+        <p:cNvGrpSpPr/>
+        <p:nvPr/>
+      </p:nvGrpSpPr>
+      <p:grpSpPr/>
+      <p:sp>
+        <p:nvSpPr>
+          <p:cNvPr id="2" name="TextBox 1"/>
+          <p:cNvSpPr txBox="1"/>
+          <p:nvPr/>
+        </p:nvSpPr>
+        <p:spPr>
+          <a:xfrm>
+            <a:off x="10634472" y="228600"/>
+            <a:ext cx="1371600" cy="457200"/>
+          </a:xfrm>
+          <a:prstGeom prst="rect">
+            <a:avLst/>
+          </a:prstGeom>
+          <a:noFill/>
+        </p:spPr>
+        <p:txBody>
+          <a:bodyPr wrap="square">
+            <a:spAutoFit/>
+          </a:bodyPr>
+          <a:lstStyle/>
+          <a:p>
+            <a:pPr algn="r"/>
+            <a:r>
+              <a:rPr sz="1200" b="0" i="0">
+                <a:solidFill>
+                  <a:srgbClr val="C9A24B"/>
+                </a:solidFill>
+                <a:latin typeface="Segoe UI"/>
+              </a:rPr>
+              <a:t>24 / 24</a:t>
             </a:r>
           </a:p>
         </p:txBody>
@@ -8316,7 +8658,7 @@
                 </a:solidFill>
                 <a:latin typeface="Segoe UI"/>
               </a:rPr>
-              <a:t>03 / 23</a:t>
+              <a:t>03 / 24</a:t>
             </a:r>
           </a:p>
         </p:txBody>
@@ -9350,7 +9692,7 @@
                 </a:solidFill>
                 <a:latin typeface="Segoe UI"/>
               </a:rPr>
-              <a:t>06 / 23</a:t>
+              <a:t>06 / 24</a:t>
             </a:r>
           </a:p>
         </p:txBody>
@@ -9551,7 +9893,7 @@
                 </a:solidFill>
                 <a:latin typeface="Segoe UI"/>
               </a:rPr>
-              <a:t>07 / 23</a:t>
+              <a:t>07 / 24</a:t>
             </a:r>
           </a:p>
         </p:txBody>
@@ -9935,7 +10277,7 @@
                 </a:solidFill>
                 <a:latin typeface="Segoe UI"/>
               </a:rPr>
-              <a:t>08 / 23</a:t>
+              <a:t>08 / 24</a:t>
             </a:r>
           </a:p>
         </p:txBody>
@@ -10367,7 +10709,7 @@
                 </a:solidFill>
                 <a:latin typeface="Segoe UI"/>
               </a:rPr>
-              <a:t>09 / 23</a:t>
+              <a:t>09 / 24</a:t>
             </a:r>
           </a:p>
         </p:txBody>

</xml_diff>